<commit_message>
Fix Ch01 slides 04/06/13 text cut by slide/bar boundaries
- Slide 04: Key Insight text overflowed its box; extended right-column
  wine rect h 4.4→4.55, moved title to y=3.85, body to y=4.18 h=1.05
- Slide 06: bottom bilingual caption cut by bar; merged 2 lines into 1
  with " · " separator, moved to y=5.0 h=0.48
- Slide 13: subtitle cut by underline rule; split to 2 lines with h=0.52,
  rule moved to y=1.24, shifted philosopher boxes to y=1.32

Co-Authored-By: Claude Opus 4.7 <noreply@anthropic.com>
</commit_message>
<xml_diff>
--- a/Ch01_Music_in_Antiquity.pptx
+++ b/Ch01_Music_in_Antiquity.pptx
@@ -5575,7 +5575,7 @@
         <p:spPr>
           <a:xfrm>
             <a:off x="365760" y="640080"/>
-            <a:ext cx="8412480" cy="320040"/>
+            <a:ext cx="8412480" cy="475488"/>
           </a:xfrm>
           <a:prstGeom prst="rect">
             <a:avLst/>
@@ -5599,7 +5599,24 @@
                 <a:ea typeface="Calibri" pitchFamily="34" charset="-122"/>
                 <a:cs typeface="Calibri" pitchFamily="34" charset="-120"/>
               </a:rPr>
-              <a:t>希臘哲學家相信音樂能直接影響人的性格與道德 · Greek philosophers believed music could affect ethical character</a:t>
+              <a:t>希臘哲學家相信音樂能直接影響人的性格與道德</a:t>
+            </a:r>
+            <a:endParaRPr lang="en-US" sz="1400" dirty="0"/>
+          </a:p>
+          <a:p>
+            <a:pPr indent="0" marL="0">
+              <a:buNone/>
+            </a:pPr>
+            <a:r>
+              <a:rPr lang="en-US" sz="1400" i="1" dirty="0">
+                <a:solidFill>
+                  <a:srgbClr val="5C3A28"/>
+                </a:solidFill>
+                <a:latin typeface="Calibri" pitchFamily="34" charset="0"/>
+                <a:ea typeface="Calibri" pitchFamily="34" charset="-122"/>
+                <a:cs typeface="Calibri" pitchFamily="34" charset="-120"/>
+              </a:rPr>
+              <a:t>Greek philosophers believed music could affect ethical character</a:t>
             </a:r>
             <a:endParaRPr lang="en-US" sz="1400" dirty="0"/>
           </a:p>
@@ -5613,7 +5630,7 @@
         </p:nvSpPr>
         <p:spPr>
           <a:xfrm>
-            <a:off x="365760" y="978408"/>
+            <a:off x="365760" y="1133856"/>
             <a:ext cx="8412480" cy="27432"/>
           </a:xfrm>
           <a:prstGeom prst="rect">
@@ -5633,8 +5650,8 @@
         </p:nvSpPr>
         <p:spPr>
           <a:xfrm>
-            <a:off x="320040" y="1051560"/>
-            <a:ext cx="4114800" cy="3749040"/>
+            <a:off x="320040" y="1207008"/>
+            <a:ext cx="4114800" cy="3703320"/>
           </a:xfrm>
           <a:prstGeom prst="rect">
             <a:avLst/>
@@ -5653,7 +5670,7 @@
         </p:nvSpPr>
         <p:spPr>
           <a:xfrm>
-            <a:off x="411480" y="1143000"/>
+            <a:off x="411480" y="1298448"/>
             <a:ext cx="3931920" cy="411480"/>
           </a:xfrm>
           <a:prstGeom prst="rect">
@@ -5692,7 +5709,7 @@
         </p:nvSpPr>
         <p:spPr>
           <a:xfrm>
-            <a:off x="411480" y="1554480"/>
+            <a:off x="411480" y="1709928"/>
             <a:ext cx="3931920" cy="292608"/>
           </a:xfrm>
           <a:prstGeom prst="rect">
@@ -5731,7 +5748,7 @@
         </p:nvSpPr>
         <p:spPr>
           <a:xfrm>
-            <a:off x="594360" y="1874520"/>
+            <a:off x="594360" y="2029968"/>
             <a:ext cx="3566160" cy="27432"/>
           </a:xfrm>
           <a:prstGeom prst="rect">
@@ -5751,8 +5768,8 @@
         </p:nvSpPr>
         <p:spPr>
           <a:xfrm>
-            <a:off x="411480" y="1920240"/>
-            <a:ext cx="3931920" cy="2834640"/>
+            <a:off x="411480" y="2084832"/>
+            <a:ext cx="3931920" cy="2761488"/>
           </a:xfrm>
           <a:prstGeom prst="rect">
             <a:avLst/>
@@ -5941,8 +5958,8 @@
         </p:nvSpPr>
         <p:spPr>
           <a:xfrm>
-            <a:off x="4709160" y="1051560"/>
-            <a:ext cx="4114800" cy="3749040"/>
+            <a:off x="4709160" y="1207008"/>
+            <a:ext cx="4114800" cy="3703320"/>
           </a:xfrm>
           <a:prstGeom prst="rect">
             <a:avLst/>
@@ -5961,7 +5978,7 @@
         </p:nvSpPr>
         <p:spPr>
           <a:xfrm>
-            <a:off x="4800600" y="1143000"/>
+            <a:off x="4800600" y="1298448"/>
             <a:ext cx="3931920" cy="411480"/>
           </a:xfrm>
           <a:prstGeom prst="rect">
@@ -6000,7 +6017,7 @@
         </p:nvSpPr>
         <p:spPr>
           <a:xfrm>
-            <a:off x="4800600" y="1554480"/>
+            <a:off x="4800600" y="1709928"/>
             <a:ext cx="3931920" cy="292608"/>
           </a:xfrm>
           <a:prstGeom prst="rect">
@@ -6039,7 +6056,7 @@
         </p:nvSpPr>
         <p:spPr>
           <a:xfrm>
-            <a:off x="4983480" y="1874520"/>
+            <a:off x="4983480" y="2029968"/>
             <a:ext cx="3566160" cy="27432"/>
           </a:xfrm>
           <a:prstGeom prst="rect">
@@ -6059,8 +6076,8 @@
         </p:nvSpPr>
         <p:spPr>
           <a:xfrm>
-            <a:off x="4800600" y="1920240"/>
-            <a:ext cx="3931920" cy="2834640"/>
+            <a:off x="4800600" y="2084832"/>
+            <a:ext cx="3931920" cy="2761488"/>
           </a:xfrm>
           <a:prstGeom prst="rect">
             <a:avLst/>
@@ -12302,7 +12319,7 @@
         <p:spPr>
           <a:xfrm>
             <a:off x="5760720" y="822960"/>
-            <a:ext cx="3017520" cy="4023360"/>
+            <a:ext cx="3017520" cy="4160520"/>
           </a:xfrm>
           <a:prstGeom prst="rect">
             <a:avLst/>
@@ -12478,8 +12495,8 @@
         </p:nvSpPr>
         <p:spPr>
           <a:xfrm>
-            <a:off x="5852160" y="3657600"/>
-            <a:ext cx="2834640" cy="320040"/>
+            <a:off x="5852160" y="3520440"/>
+            <a:ext cx="2834640" cy="274320"/>
           </a:xfrm>
           <a:prstGeom prst="rect">
             <a:avLst/>
@@ -12514,8 +12531,8 @@
         </p:nvSpPr>
         <p:spPr>
           <a:xfrm>
-            <a:off x="5852160" y="3977640"/>
-            <a:ext cx="2834640" cy="822960"/>
+            <a:off x="5852160" y="3822192"/>
+            <a:ext cx="2834640" cy="960120"/>
           </a:xfrm>
           <a:prstGeom prst="rect">
             <a:avLst/>
@@ -14094,8 +14111,8 @@
         </p:nvSpPr>
         <p:spPr>
           <a:xfrm>
-            <a:off x="365760" y="4663440"/>
-            <a:ext cx="8412480" cy="320040"/>
+            <a:off x="365760" y="4572000"/>
+            <a:ext cx="8412480" cy="438912"/>
           </a:xfrm>
           <a:prstGeom prst="rect">
             <a:avLst/>
@@ -14119,24 +14136,7 @@
                 <a:ea typeface="Calibri" pitchFamily="34" charset="-122"/>
                 <a:cs typeface="Calibri" pitchFamily="34" charset="-120"/>
               </a:rPr>
-              <a:t>烏爾出土的豎琴（ca. 2500 BCE）是現存最早的撥弦樂器實物之一</a:t>
-            </a:r>
-            <a:endParaRPr lang="en-US" sz="1400" dirty="0"/>
-          </a:p>
-          <a:p>
-            <a:pPr indent="0" marL="0">
-              <a:buNone/>
-            </a:pPr>
-            <a:r>
-              <a:rPr lang="en-US" sz="1400" i="1" dirty="0">
-                <a:solidFill>
-                  <a:srgbClr val="5C3A28"/>
-                </a:solidFill>
-                <a:latin typeface="Calibri" pitchFamily="34" charset="0"/>
-                <a:ea typeface="Calibri" pitchFamily="34" charset="-122"/>
-                <a:cs typeface="Calibri" pitchFamily="34" charset="-120"/>
-              </a:rPr>
-              <a:t>The lyres and harps from Ur (ca. 2500 BCE) are among the earliest surviving plucked string instruments.</a:t>
+              <a:t>烏爾出土的豎琴（ca. 2500 BCE）是現存最早的撥弦樂器實物之一 · The lyres and harps from Ur are among the earliest surviving plucked string instruments</a:t>
             </a:r>
             <a:endParaRPr lang="en-US" sz="1400" dirty="0"/>
           </a:p>

</xml_diff>